<commit_message>
D-2 수정 작업: OpenAI API 우선 없으면 Ollama 적용
</commit_message>
<xml_diff>
--- a/Lecture/64/00-DAY64-OVERVIEW.pptx
+++ b/Lecture/64/00-DAY64-OVERVIEW.pptx
@@ -3098,7 +3098,7 @@
                   <a:schemeClr val="accent1"/>
                 </a:solidFill>
               </a:rPr>
-              <a:t>로컬 LLM · 오늘 실습</a:t>
+              <a:t>로컬 LLM · 대체용</a:t>
             </a:r>
             <a:endParaRPr lang="en-US" sz="1900" dirty="0"/>
           </a:p>
@@ -3417,7 +3417,7 @@
                   <a:schemeClr val="accent5"/>
                 </a:solidFill>
               </a:rPr>
-              <a:t>클라우드 LLM API</a:t>
+              <a:t>클라우드 API · 오늘 실습</a:t>
             </a:r>
             <a:endParaRPr lang="en-US" sz="1900" dirty="0"/>
           </a:p>
@@ -3453,7 +3453,7 @@
                   <a:schemeClr val="accent6"/>
                 </a:solidFill>
               </a:rPr>
-              <a:t>OpenAI · Anthropic · Gemini</a:t>
+              <a:t>OpenAI gpt-4.1-mini 등</a:t>
             </a:r>
             <a:endParaRPr lang="en-US" sz="1400" dirty="0"/>
           </a:p>
@@ -3736,7 +3736,7 @@
                   <a:schemeClr val="bg1"/>
                 </a:solidFill>
               </a:rPr>
-              <a:t>같은 문의 4건 분류</a:t>
+              <a:t>같은 문의 4건 분류 (gemma3:4b도 4/4)</a:t>
             </a:r>
             <a:endParaRPr lang="en-US" sz="1600" dirty="0"/>
           </a:p>
@@ -3772,7 +3772,7 @@
                   <a:schemeClr val="accent4"/>
                 </a:solidFill>
               </a:rPr>
-              <a:t>0/4</a:t>
+              <a:t>1/4</a:t>
             </a:r>
             <a:endParaRPr lang="en-US" sz="4000" dirty="0"/>
           </a:p>
@@ -3808,7 +3808,7 @@
                   <a:schemeClr val="bg1"/>
                 </a:solidFill>
               </a:rPr>
-              <a:t>gemma3:1b</a:t>
+              <a:t>gemma3:1b 대체</a:t>
             </a:r>
             <a:endParaRPr lang="en-US" sz="1600" dirty="0"/>
           </a:p>
@@ -3894,7 +3894,7 @@
                   <a:schemeClr val="bg1"/>
                 </a:solidFill>
               </a:rPr>
-              <a:t>gemma3:4b</a:t>
+              <a:t>gpt-4.1-mini</a:t>
             </a:r>
             <a:endParaRPr lang="en-US" sz="1600" dirty="0"/>
           </a:p>
@@ -3908,7 +3908,7 @@
                   <a:schemeClr val="bg1"/>
                 </a:solidFill>
               </a:rPr>
-              <a:t>3.3GB · 약 1.7초</a:t>
+              <a:t>OpenAI · 약 1초</a:t>
             </a:r>
             <a:endParaRPr lang="en-US" sz="1600" dirty="0"/>
           </a:p>
@@ -6218,7 +6218,7 @@
                   <a:schemeClr val="tx1"/>
                 </a:solidFill>
               </a:rPr>
-              <a:t>사례: 사내 IT 기술 지원 문의</a:t>
+              <a:t>사례: 사내 IT 문의</a:t>
             </a:r>
             <a:endParaRPr lang="en-US" sz="1600" dirty="0"/>
           </a:p>
@@ -6268,7 +6268,7 @@
                   <a:schemeClr val="accent6"/>
                 </a:solidFill>
               </a:rPr>
-              <a:t>80~82일차 단위 프로젝트 '지능형 기술 지원 자동화'의 가장 작은 버전</a:t>
+              <a:t>80~82일차 단위 프로젝트 '지능형 Tech Support 자동화'의 가장 작은 버전</a:t>
             </a:r>
             <a:endParaRPr lang="en-US" sz="1400" dirty="0"/>
           </a:p>
@@ -6469,7 +6469,7 @@
                 <a:ea typeface="Courier New" pitchFamily="34" charset="-122"/>
                 <a:cs typeface="Courier New" pitchFamily="34" charset="-120"/>
               </a:rPr>
-              <a:t>$ export MINIFLOW_LLM=ollama</a:t>
+              <a:t>$ uv run miniflow check</a:t>
             </a:r>
             <a:endParaRPr lang="en-US" sz="1700" dirty="0"/>
           </a:p>
@@ -6609,7 +6609,7 @@
                 <a:ea typeface="Courier New" pitchFamily="34" charset="-122"/>
                 <a:cs typeface="Courier New" pitchFamily="34" charset="-120"/>
               </a:rPr>
-              <a:t>네, 비가 오므로 우산이 필요할 것 같습니다.</a:t>
+              <a:t>네, 제주에 비가 오고 비 올 확률이 80%이므로 우산이 필요합니다.</a:t>
             </a:r>
             <a:endParaRPr lang="en-US" sz="1700" dirty="0"/>
           </a:p>
@@ -6911,7 +6911,7 @@
                   <a:schemeClr val="tx1"/>
                 </a:solidFill>
               </a:rPr>
-              <a:t>노드 추가 · Mock과 Ollama 비교</a:t>
+              <a:t>노드 추가 · Mock·OpenAI·Ollama 비교</a:t>
             </a:r>
             <a:endParaRPr lang="en-US" sz="1500" dirty="0"/>
           </a:p>
@@ -7098,7 +7098,7 @@
                   <a:schemeClr val="accent6"/>
                 </a:solidFill>
               </a:rPr>
-              <a:t>WSL + Ollama 로컬 LLM(gemma3:4b) · API 키 불필요 · 노코드 도구(n8n)는 65일차부터</a:t>
+              <a:t>OpenAI API(gpt-4.1-mini, 키는 .env) · 안 되면 Ollama(gemma3:4b) · 노코드 도구(n8n)는 65일차부터</a:t>
             </a:r>
             <a:endParaRPr lang="en-US" sz="1400" dirty="0"/>
           </a:p>

</xml_diff>